<commit_message>
- [Documentation] No code changes - Added 2 new progress updates - Added a new session summary
</commit_message>
<xml_diff>
--- a/docs/progress-updates/progress_update_2026-08-28_uplink.pptx
+++ b/docs/progress-updates/progress_update_2026-08-28_uplink.pptx
@@ -12,6 +12,7 @@
     <p:sldId id="260" r:id="rId11"/>
     <p:sldId id="261" r:id="rId12"/>
     <p:sldId id="262" r:id="rId13"/>
+    <p:sldId id="264" r:id="rId15"/>
     <p:sldId id="263" r:id="rId14"/>
   </p:sldIdLst>
   <p:sldSz cx="12191695" cy="6858000" type="screen4x3"/>
@@ -7831,6 +7832,751 @@
                 <a:latin typeface="Calibri"/>
               </a:rPr>
               <a:t>Prove stable reconnect under load on one SIM7600G-H first — the hardware isn't on the critical path yet.</a:t>
+            </a:r>
+          </a:p>
+        </p:txBody>
+      </p:sp>
+    </p:spTree>
+  </p:cSld>
+  <p:clrMapOvr>
+    <a:masterClrMapping/>
+  </p:clrMapOvr>
+</p:sld>
+</file>
+
+<file path=ppt/slides/slide9.xml><?xml version="1.0" encoding="utf-8"?>
+<p:sld xmlns:a="http://schemas.openxmlformats.org/drawingml/2006/main" xmlns:p="http://schemas.openxmlformats.org/presentationml/2006/main" xmlns:r="http://schemas.openxmlformats.org/officeDocument/2006/relationships">
+  <p:cSld>
+    <p:spTree>
+      <p:nvGrpSpPr>
+        <p:cNvPr id="1" name=""/>
+        <p:cNvGrpSpPr/>
+        <p:nvPr/>
+      </p:nvGrpSpPr>
+      <p:grpSpPr/>
+      <p:sp>
+        <p:nvSpPr>
+          <p:cNvPr id="2" name="Rectangle 1"/>
+          <p:cNvSpPr/>
+          <p:nvPr/>
+        </p:nvSpPr>
+        <p:spPr>
+          <a:xfrm>
+            <a:off x="0" y="0"/>
+            <a:ext cx="12191695" cy="6858000"/>
+          </a:xfrm>
+          <a:prstGeom prst="rect">
+            <a:avLst/>
+          </a:prstGeom>
+          <a:solidFill>
+            <a:srgbClr val="E8EEFB"/>
+          </a:solidFill>
+          <a:ln>
+            <a:noFill/>
+          </a:ln>
+          <a:effectLst/>
+        </p:spPr>
+        <p:style>
+          <a:lnRef idx="1">
+            <a:schemeClr val="accent1"/>
+          </a:lnRef>
+          <a:fillRef idx="3">
+            <a:schemeClr val="accent1"/>
+          </a:fillRef>
+          <a:effectRef idx="2">
+            <a:schemeClr val="accent1"/>
+          </a:effectRef>
+          <a:fontRef idx="minor">
+            <a:schemeClr val="lt1"/>
+          </a:fontRef>
+        </p:style>
+        <p:txBody>
+          <a:bodyPr rtlCol="0" anchor="ctr"/>
+          <a:lstStyle/>
+          <a:p>
+            <a:pPr algn="ctr"/>
+          </a:p>
+        </p:txBody>
+      </p:sp>
+      <p:sp>
+        <p:nvSpPr>
+          <p:cNvPr id="3" name="TextBox 2"/>
+          <p:cNvSpPr txBox="1"/>
+          <p:nvPr/>
+        </p:nvSpPr>
+        <p:spPr>
+          <a:xfrm>
+            <a:off x="548640" y="320040"/>
+            <a:ext cx="11064240" cy="731520"/>
+          </a:xfrm>
+          <a:prstGeom prst="rect">
+            <a:avLst/>
+          </a:prstGeom>
+          <a:noFill/>
+        </p:spPr>
+        <p:txBody>
+          <a:bodyPr wrap="square" anchor="t">
+            <a:spAutoFit/>
+          </a:bodyPr>
+          <a:lstStyle/>
+          <a:p>
+            <a:pPr algn="l">
+              <a:lnSpc>
+                <a:spcPct val="100000"/>
+              </a:lnSpc>
+              <a:spcAft>
+                <a:spcPts val="0"/>
+              </a:spcAft>
+            </a:pPr>
+            <a:r>
+              <a:rPr sz="3000" b="1" i="0">
+                <a:solidFill>
+                  <a:srgbClr val="1A1A2E"/>
+                </a:solidFill>
+                <a:latin typeface="Calibri"/>
+              </a:rPr>
+              <a:t>Concrete Parts — What Each Option Buys</a:t>
+            </a:r>
+          </a:p>
+        </p:txBody>
+      </p:sp>
+      <p:sp>
+        <p:nvSpPr>
+          <p:cNvPr id="4" name="Rounded Rectangle 3"/>
+          <p:cNvSpPr/>
+          <p:nvPr/>
+        </p:nvSpPr>
+        <p:spPr>
+          <a:xfrm>
+            <a:off x="548640" y="1234440"/>
+            <a:ext cx="11064240" cy="1600200"/>
+          </a:xfrm>
+          <a:prstGeom prst="roundRect">
+            <a:avLst>
+              <a:gd name="adj" fmla="val 8000"/>
+            </a:avLst>
+          </a:prstGeom>
+          <a:solidFill>
+            <a:srgbClr val="FFFFFF"/>
+          </a:solidFill>
+          <a:ln>
+            <a:noFill/>
+          </a:ln>
+          <a:effectLst/>
+        </p:spPr>
+        <p:style>
+          <a:lnRef idx="1">
+            <a:schemeClr val="accent1"/>
+          </a:lnRef>
+          <a:fillRef idx="3">
+            <a:schemeClr val="accent1"/>
+          </a:fillRef>
+          <a:effectRef idx="2">
+            <a:schemeClr val="accent1"/>
+          </a:effectRef>
+          <a:fontRef idx="minor">
+            <a:schemeClr val="lt1"/>
+          </a:fontRef>
+        </p:style>
+        <p:txBody>
+          <a:bodyPr rtlCol="0" anchor="ctr"/>
+          <a:lstStyle/>
+          <a:p>
+            <a:pPr algn="ctr"/>
+          </a:p>
+        </p:txBody>
+      </p:sp>
+      <p:sp>
+        <p:nvSpPr>
+          <p:cNvPr id="5" name="Rectangle 4"/>
+          <p:cNvSpPr/>
+          <p:nvPr/>
+        </p:nvSpPr>
+        <p:spPr>
+          <a:xfrm>
+            <a:off x="548640" y="1234440"/>
+            <a:ext cx="82296" cy="1600200"/>
+          </a:xfrm>
+          <a:prstGeom prst="rect">
+            <a:avLst/>
+          </a:prstGeom>
+          <a:solidFill>
+            <a:srgbClr val="F2A93B"/>
+          </a:solidFill>
+          <a:ln>
+            <a:noFill/>
+          </a:ln>
+          <a:effectLst/>
+        </p:spPr>
+        <p:style>
+          <a:lnRef idx="1">
+            <a:schemeClr val="accent1"/>
+          </a:lnRef>
+          <a:fillRef idx="3">
+            <a:schemeClr val="accent1"/>
+          </a:fillRef>
+          <a:effectRef idx="2">
+            <a:schemeClr val="accent1"/>
+          </a:effectRef>
+          <a:fontRef idx="minor">
+            <a:schemeClr val="lt1"/>
+          </a:fontRef>
+        </p:style>
+        <p:txBody>
+          <a:bodyPr rtlCol="0" anchor="ctr"/>
+          <a:lstStyle/>
+          <a:p>
+            <a:pPr algn="ctr"/>
+          </a:p>
+        </p:txBody>
+      </p:sp>
+      <p:sp>
+        <p:nvSpPr>
+          <p:cNvPr id="6" name="TextBox 5"/>
+          <p:cNvSpPr txBox="1"/>
+          <p:nvPr/>
+        </p:nvSpPr>
+        <p:spPr>
+          <a:xfrm>
+            <a:off x="868680" y="1371600"/>
+            <a:ext cx="10424160" cy="365760"/>
+          </a:xfrm>
+          <a:prstGeom prst="rect">
+            <a:avLst/>
+          </a:prstGeom>
+          <a:noFill/>
+        </p:spPr>
+        <p:txBody>
+          <a:bodyPr wrap="square" anchor="t">
+            <a:spAutoFit/>
+          </a:bodyPr>
+          <a:lstStyle/>
+          <a:p>
+            <a:pPr algn="l">
+              <a:lnSpc>
+                <a:spcPct val="100000"/>
+              </a:lnSpc>
+              <a:spcAft>
+                <a:spcPts val="0"/>
+              </a:spcAft>
+            </a:pPr>
+            <a:r>
+              <a:rPr sz="1600" b="1" i="0">
+                <a:solidFill>
+                  <a:srgbClr val="1E2761"/>
+                </a:solidFill>
+                <a:latin typeface="Calibri"/>
+              </a:rPr>
+              <a:t>Option A — SIM7600G-H 4G HAT build</a:t>
+            </a:r>
+          </a:p>
+        </p:txBody>
+      </p:sp>
+      <p:sp>
+        <p:nvSpPr>
+          <p:cNvPr id="7" name="TextBox 6"/>
+          <p:cNvSpPr txBox="1"/>
+          <p:nvPr/>
+        </p:nvSpPr>
+        <p:spPr>
+          <a:xfrm>
+            <a:off x="868680" y="1783080"/>
+            <a:ext cx="10424160" cy="914400"/>
+          </a:xfrm>
+          <a:prstGeom prst="rect">
+            <a:avLst/>
+          </a:prstGeom>
+          <a:noFill/>
+        </p:spPr>
+        <p:txBody>
+          <a:bodyPr wrap="square">
+            <a:spAutoFit/>
+          </a:bodyPr>
+          <a:lstStyle/>
+          <a:p>
+            <a:pPr>
+              <a:spcAft>
+                <a:spcPts val="300"/>
+              </a:spcAft>
+            </a:pPr>
+            <a:r>
+              <a:rPr sz="1300">
+                <a:solidFill>
+                  <a:srgbClr val="1A1A2E"/>
+                </a:solidFill>
+                <a:latin typeface="Calibri"/>
+              </a:rPr>
+              <a:t>•  Waveshare SIM7600G-H 4G HAT — the part already in the BOM, ~$60-85 (Waveshare direct / Amazon); the "(B)" variant adds GNSS</a:t>
+            </a:r>
+          </a:p>
+          <a:p>
+            <a:pPr>
+              <a:spcAft>
+                <a:spcPts val="300"/>
+              </a:spcAft>
+            </a:pPr>
+            <a:r>
+              <a:rPr sz="1300">
+                <a:solidFill>
+                  <a:srgbClr val="1A1A2E"/>
+                </a:solidFill>
+                <a:latin typeface="Calibri"/>
+              </a:rPr>
+              <a:t>•  Better-supported alternative: Sixfab Base HAT + Quectel EG25-G, ~$75-100 — Sixfab's connection manager replaces watchdog/reconnect code we'd otherwise write</a:t>
+            </a:r>
+          </a:p>
+          <a:p>
+            <a:pPr>
+              <a:spcAft>
+                <a:spcPts val="300"/>
+              </a:spcAft>
+            </a:pPr>
+            <a:r>
+              <a:rPr sz="1300">
+                <a:solidFill>
+                  <a:srgbClr val="1A1A2E"/>
+                </a:solidFill>
+                <a:latin typeface="Calibri"/>
+              </a:rPr>
+              <a:t>•  Raspberry Pi 27W USB-C PSU (5.1V / 5A), ~$14 — one supply with headroom for the modem's ~2A TX bursts</a:t>
+            </a:r>
+          </a:p>
+          <a:p>
+            <a:pPr>
+              <a:spcAft>
+                <a:spcPts val="300"/>
+              </a:spcAft>
+            </a:pPr>
+            <a:r>
+              <a:rPr sz="1300">
+                <a:solidFill>
+                  <a:srgbClr val="1A1A2E"/>
+                </a:solidFill>
+                <a:latin typeface="Calibri"/>
+              </a:rPr>
+              <a:t>•  2x SMA LTE paddle antennas (~$10), stick-on heatsink for the module, PWRKEY jumpered to a spare GPIO for boot pulse + software reset</a:t>
+            </a:r>
+          </a:p>
+        </p:txBody>
+      </p:sp>
+      <p:sp>
+        <p:nvSpPr>
+          <p:cNvPr id="8" name="Rounded Rectangle 7"/>
+          <p:cNvSpPr/>
+          <p:nvPr/>
+        </p:nvSpPr>
+        <p:spPr>
+          <a:xfrm>
+            <a:off x="548640" y="3063240"/>
+            <a:ext cx="11064240" cy="1600200"/>
+          </a:xfrm>
+          <a:prstGeom prst="roundRect">
+            <a:avLst>
+              <a:gd name="adj" fmla="val 8000"/>
+            </a:avLst>
+          </a:prstGeom>
+          <a:solidFill>
+            <a:srgbClr val="FFFFFF"/>
+          </a:solidFill>
+          <a:ln>
+            <a:noFill/>
+          </a:ln>
+          <a:effectLst/>
+        </p:spPr>
+        <p:style>
+          <a:lnRef idx="1">
+            <a:schemeClr val="accent1"/>
+          </a:lnRef>
+          <a:fillRef idx="3">
+            <a:schemeClr val="accent1"/>
+          </a:fillRef>
+          <a:effectRef idx="2">
+            <a:schemeClr val="accent1"/>
+          </a:effectRef>
+          <a:fontRef idx="minor">
+            <a:schemeClr val="lt1"/>
+          </a:fontRef>
+        </p:style>
+        <p:txBody>
+          <a:bodyPr rtlCol="0" anchor="ctr"/>
+          <a:lstStyle/>
+          <a:p>
+            <a:pPr algn="ctr"/>
+          </a:p>
+        </p:txBody>
+      </p:sp>
+      <p:sp>
+        <p:nvSpPr>
+          <p:cNvPr id="9" name="Rectangle 8"/>
+          <p:cNvSpPr/>
+          <p:nvPr/>
+        </p:nvSpPr>
+        <p:spPr>
+          <a:xfrm>
+            <a:off x="548640" y="3063240"/>
+            <a:ext cx="82296" cy="1600200"/>
+          </a:xfrm>
+          <a:prstGeom prst="rect">
+            <a:avLst/>
+          </a:prstGeom>
+          <a:solidFill>
+            <a:srgbClr val="F2A93B"/>
+          </a:solidFill>
+          <a:ln>
+            <a:noFill/>
+          </a:ln>
+          <a:effectLst/>
+        </p:spPr>
+        <p:style>
+          <a:lnRef idx="1">
+            <a:schemeClr val="accent1"/>
+          </a:lnRef>
+          <a:fillRef idx="3">
+            <a:schemeClr val="accent1"/>
+          </a:fillRef>
+          <a:effectRef idx="2">
+            <a:schemeClr val="accent1"/>
+          </a:effectRef>
+          <a:fontRef idx="minor">
+            <a:schemeClr val="lt1"/>
+          </a:fontRef>
+        </p:style>
+        <p:txBody>
+          <a:bodyPr rtlCol="0" anchor="ctr"/>
+          <a:lstStyle/>
+          <a:p>
+            <a:pPr algn="ctr"/>
+          </a:p>
+        </p:txBody>
+      </p:sp>
+      <p:sp>
+        <p:nvSpPr>
+          <p:cNvPr id="10" name="TextBox 9"/>
+          <p:cNvSpPr txBox="1"/>
+          <p:nvPr/>
+        </p:nvSpPr>
+        <p:spPr>
+          <a:xfrm>
+            <a:off x="868680" y="3200400"/>
+            <a:ext cx="10424160" cy="365760"/>
+          </a:xfrm>
+          <a:prstGeom prst="rect">
+            <a:avLst/>
+          </a:prstGeom>
+          <a:noFill/>
+        </p:spPr>
+        <p:txBody>
+          <a:bodyPr wrap="square" anchor="t">
+            <a:spAutoFit/>
+          </a:bodyPr>
+          <a:lstStyle/>
+          <a:p>
+            <a:pPr algn="l">
+              <a:lnSpc>
+                <a:spcPct val="100000"/>
+              </a:lnSpc>
+              <a:spcAft>
+                <a:spcPts val="0"/>
+              </a:spcAft>
+            </a:pPr>
+            <a:r>
+              <a:rPr sz="1600" b="1" i="0">
+                <a:solidFill>
+                  <a:srgbClr val="1E2761"/>
+                </a:solidFill>
+                <a:latin typeface="Calibri"/>
+              </a:rPr>
+              <a:t>Option B — Standalone 4G router</a:t>
+            </a:r>
+          </a:p>
+        </p:txBody>
+      </p:sp>
+      <p:sp>
+        <p:nvSpPr>
+          <p:cNvPr id="11" name="TextBox 10"/>
+          <p:cNvSpPr txBox="1"/>
+          <p:nvPr/>
+        </p:nvSpPr>
+        <p:spPr>
+          <a:xfrm>
+            <a:off x="868680" y="3611880"/>
+            <a:ext cx="10424160" cy="914400"/>
+          </a:xfrm>
+          <a:prstGeom prst="rect">
+            <a:avLst/>
+          </a:prstGeom>
+          <a:noFill/>
+        </p:spPr>
+        <p:txBody>
+          <a:bodyPr wrap="square">
+            <a:spAutoFit/>
+          </a:bodyPr>
+          <a:lstStyle/>
+          <a:p>
+            <a:pPr>
+              <a:spcAft>
+                <a:spcPts val="300"/>
+              </a:spcAft>
+            </a:pPr>
+            <a:r>
+              <a:rPr sz="1300">
+                <a:solidFill>
+                  <a:srgbClr val="1A1A2E"/>
+                </a:solidFill>
+                <a:latin typeface="Calibri"/>
+              </a:rPr>
+              <a:t>•  Baseline: TP-Link Archer MR200 — LTE Cat-4, 4x Ethernet, web diagnostics UI, mains PSU included, ~$65-110</a:t>
+            </a:r>
+          </a:p>
+          <a:p>
+            <a:pPr>
+              <a:spcAft>
+                <a:spcPts val="300"/>
+              </a:spcAft>
+            </a:pPr>
+            <a:r>
+              <a:rPr sz="1300">
+                <a:solidFill>
+                  <a:srgbClr val="1A1A2E"/>
+                </a:solidFill>
+                <a:latin typeface="Calibri"/>
+              </a:rPr>
+              <a:t>•  Same class: Huawei B311 / B535, ~$55-80 — mains-powered, one RJ45 LAN</a:t>
+            </a:r>
+          </a:p>
+          <a:p>
+            <a:pPr>
+              <a:spcAft>
+                <a:spcPts val="300"/>
+              </a:spcAft>
+            </a:pPr>
+            <a:r>
+              <a:rPr sz="1300">
+                <a:solidFill>
+                  <a:srgbClr val="1A1A2E"/>
+                </a:solidFill>
+                <a:latin typeface="Calibri"/>
+              </a:rPr>
+              <a:t>•  Single-supply option: GL.iNet GL-XE300 "Puli" — 5V USB-C in, OpenWrt diagnostics, ~$110-130; avoids a second mains voltage but still its own cable/port</a:t>
+            </a:r>
+          </a:p>
+          <a:p>
+            <a:pPr>
+              <a:spcAft>
+                <a:spcPts val="300"/>
+              </a:spcAft>
+            </a:pPr>
+            <a:r>
+              <a:rPr sz="1300">
+                <a:solidFill>
+                  <a:srgbClr val="1A1A2E"/>
+                </a:solidFill>
+                <a:latin typeface="Calibri"/>
+              </a:rPr>
+              <a:t>•  Pi connects over its free Ethernet port by DHCP — nothing else to add on the Pi side</a:t>
+            </a:r>
+          </a:p>
+        </p:txBody>
+      </p:sp>
+      <p:sp>
+        <p:nvSpPr>
+          <p:cNvPr id="12" name="Rounded Rectangle 11"/>
+          <p:cNvSpPr/>
+          <p:nvPr/>
+        </p:nvSpPr>
+        <p:spPr>
+          <a:xfrm>
+            <a:off x="548640" y="4892040"/>
+            <a:ext cx="11064240" cy="1600200"/>
+          </a:xfrm>
+          <a:prstGeom prst="roundRect">
+            <a:avLst>
+              <a:gd name="adj" fmla="val 8000"/>
+            </a:avLst>
+          </a:prstGeom>
+          <a:solidFill>
+            <a:srgbClr val="FFFFFF"/>
+          </a:solidFill>
+          <a:ln>
+            <a:noFill/>
+          </a:ln>
+          <a:effectLst/>
+        </p:spPr>
+        <p:style>
+          <a:lnRef idx="1">
+            <a:schemeClr val="accent1"/>
+          </a:lnRef>
+          <a:fillRef idx="3">
+            <a:schemeClr val="accent1"/>
+          </a:fillRef>
+          <a:effectRef idx="2">
+            <a:schemeClr val="accent1"/>
+          </a:effectRef>
+          <a:fontRef idx="minor">
+            <a:schemeClr val="lt1"/>
+          </a:fontRef>
+        </p:style>
+        <p:txBody>
+          <a:bodyPr rtlCol="0" anchor="ctr"/>
+          <a:lstStyle/>
+          <a:p>
+            <a:pPr algn="ctr"/>
+          </a:p>
+        </p:txBody>
+      </p:sp>
+      <p:sp>
+        <p:nvSpPr>
+          <p:cNvPr id="13" name="Rectangle 12"/>
+          <p:cNvSpPr/>
+          <p:nvPr/>
+        </p:nvSpPr>
+        <p:spPr>
+          <a:xfrm>
+            <a:off x="548640" y="4892040"/>
+            <a:ext cx="82296" cy="1600200"/>
+          </a:xfrm>
+          <a:prstGeom prst="rect">
+            <a:avLst/>
+          </a:prstGeom>
+          <a:solidFill>
+            <a:srgbClr val="F2A93B"/>
+          </a:solidFill>
+          <a:ln>
+            <a:noFill/>
+          </a:ln>
+          <a:effectLst/>
+        </p:spPr>
+        <p:style>
+          <a:lnRef idx="1">
+            <a:schemeClr val="accent1"/>
+          </a:lnRef>
+          <a:fillRef idx="3">
+            <a:schemeClr val="accent1"/>
+          </a:fillRef>
+          <a:effectRef idx="2">
+            <a:schemeClr val="accent1"/>
+          </a:effectRef>
+          <a:fontRef idx="minor">
+            <a:schemeClr val="lt1"/>
+          </a:fontRef>
+        </p:style>
+        <p:txBody>
+          <a:bodyPr rtlCol="0" anchor="ctr"/>
+          <a:lstStyle/>
+          <a:p>
+            <a:pPr algn="ctr"/>
+          </a:p>
+        </p:txBody>
+      </p:sp>
+      <p:sp>
+        <p:nvSpPr>
+          <p:cNvPr id="14" name="TextBox 13"/>
+          <p:cNvSpPr txBox="1"/>
+          <p:nvPr/>
+        </p:nvSpPr>
+        <p:spPr>
+          <a:xfrm>
+            <a:off x="868680" y="5029200"/>
+            <a:ext cx="10424160" cy="365760"/>
+          </a:xfrm>
+          <a:prstGeom prst="rect">
+            <a:avLst/>
+          </a:prstGeom>
+          <a:noFill/>
+        </p:spPr>
+        <p:txBody>
+          <a:bodyPr wrap="square" anchor="t">
+            <a:spAutoFit/>
+          </a:bodyPr>
+          <a:lstStyle/>
+          <a:p>
+            <a:pPr algn="l">
+              <a:lnSpc>
+                <a:spcPct val="100000"/>
+              </a:lnSpc>
+              <a:spcAft>
+                <a:spcPts val="0"/>
+              </a:spcAft>
+            </a:pPr>
+            <a:r>
+              <a:rPr sz="1600" b="1" i="0">
+                <a:solidFill>
+                  <a:srgbClr val="1E2761"/>
+                </a:solidFill>
+                <a:latin typeface="Calibri"/>
+              </a:rPr>
+              <a:t>Either way</a:t>
+            </a:r>
+          </a:p>
+        </p:txBody>
+      </p:sp>
+      <p:sp>
+        <p:nvSpPr>
+          <p:cNvPr id="15" name="TextBox 14"/>
+          <p:cNvSpPr txBox="1"/>
+          <p:nvPr/>
+        </p:nvSpPr>
+        <p:spPr>
+          <a:xfrm>
+            <a:off x="868680" y="5440680"/>
+            <a:ext cx="10424160" cy="914400"/>
+          </a:xfrm>
+          <a:prstGeom prst="rect">
+            <a:avLst/>
+          </a:prstGeom>
+          <a:noFill/>
+        </p:spPr>
+        <p:txBody>
+          <a:bodyPr wrap="square">
+            <a:spAutoFit/>
+          </a:bodyPr>
+          <a:lstStyle/>
+          <a:p>
+            <a:pPr>
+              <a:spcAft>
+                <a:spcPts val="300"/>
+              </a:spcAft>
+            </a:pPr>
+            <a:r>
+              <a:rPr sz="1300">
+                <a:solidFill>
+                  <a:srgbClr val="1A1A2E"/>
+                </a:solidFill>
+                <a:latin typeface="Calibri"/>
+              </a:rPr>
+              <a:t>•  Local prepaid data SIM (Globe / Smart / DITO), standard 4G APN — recurring cost already approved</a:t>
+            </a:r>
+          </a:p>
+          <a:p>
+            <a:pPr>
+              <a:spcAft>
+                <a:spcPts val="300"/>
+              </a:spcAft>
+            </a:pPr>
+            <a:r>
+              <a:rPr sz="1300">
+                <a:solidFill>
+                  <a:srgbClr val="1A1A2E"/>
+                </a:solidFill>
+                <a:latin typeface="Calibri"/>
+              </a:rPr>
+              <a:t>•  All candidate modems/routers cover PH LTE bands (B3 / B28 / B41) and the wider SEA set; confirm against the chosen carrier before ordering</a:t>
+            </a:r>
+          </a:p>
+          <a:p>
+            <a:pPr>
+              <a:spcAft>
+                <a:spcPts val="300"/>
+              </a:spcAft>
+            </a:pPr>
+            <a:r>
+              <a:rPr sz="1300">
+                <a:solidFill>
+                  <a:srgbClr val="1A1A2E"/>
+                </a:solidFill>
+                <a:latin typeface="Calibri"/>
+              </a:rPr>
+              <a:t>•  Antenna cable gland / strain relief where the lead exits the wooden enclosure</a:t>
             </a:r>
           </a:p>
         </p:txBody>

</xml_diff>